<commit_message>
changed pp to bps
</commit_message>
<xml_diff>
--- a/presentations/0602_Stablecoin_Exorbitant_Privilege.pptx
+++ b/presentations/0602_Stablecoin_Exorbitant_Privilege.pptx
@@ -720,7 +720,7 @@
           <a:lstStyle/>
           <a:p>
             <a:r>
-              <a:t>This is the direct visual comparison between the original and corrected models. The top row shows what our original event study produced: positive 8.9 pp for LUNA, positive 8.85 pp for USDT, and negative 18 pp for SVB. Every graph shows a clear dramatic trend — either up or down. The bottom row shows the corrected first-difference model: all three events produce CARs within a few hundredths of a percentage point from zero. The contrast is stark. The top row looked like strong evidence. The bottom row is the honest result. The key insight is that the top row's dramatic trend was the Fed raising rates — not the stablecoin events themselves. Once we remove the trend by modelling daily changes instead of levels, the stablecoin-specific effect on the Treasury spread is indistinguishable from zero.</a:t>
+              <a:t>This is the direct visual comparison between the original and corrected models. The top row shows what our original event study produced: positive 891 bps for LUNA, positive 885 bps for USDT, and negative 1,801 bps for SVB. Every graph shows a clear dramatic trend — either up or down. The bottom row shows the corrected first-difference model: all three events produce CARs within a few basis points of zero. The contrast is stark. The top row looked like strong evidence. The bottom row is the honest result. The key insight is that the top row's dramatic trend was the Fed raising rates — not the stablecoin events themselves. Once we remove the trend by modelling daily changes instead of levels, the stablecoin-specific effect on the Treasury spread is indistinguishable from zero.</a:t>
             </a:r>
           </a:p>
         </p:txBody>
@@ -790,7 +790,7 @@
           <a:lstStyle/>
           <a:p>
             <a:r>
-              <a:t>Here are the actual CAR paths from the corrected first-difference model. All three end near zero at day plus 20. Let me explain what each graph shows. For LUNA and USDT on the left and centre: the spread was volatile but drifted around zero throughout. Tether was selling T-bills to meet redemptions, but at the same time the financial panic caused a general flight to safety — other investors were buying T-bills. The two forces cancelled. For SVB on the right: notice the sharp drop to about negative 0.5 pp around day plus 5. This is the acute flight-to-safety spike — the T-bill spread compressed sharply as investors rushed out of bank deposits and into T-bills. But it recovered back to near zero by day plus 20 as markets stabilised. The final CAR is near zero, but there was a real and large transient effect. Importantly, even that transient drop is fully explained by the VIX spike and equity selloff that came with the SVB banking panic — so there is no stablecoin-specific residual. The key reading: a flat line at zero means no effect. These graphs show lines that hover near zero, occasionally dipping or rising, but without the sustained directional trend we would need to call it significant.</a:t>
+              <a:t>Here are the actual CAR paths from the corrected first-difference model. All three end near zero at day plus 20. Let me explain what each graph shows. For LUNA and USDT on the left and centre: the spread was volatile but drifted around zero throughout. Tether was selling T-bills to meet redemptions, but at the same time the financial panic caused a general flight to safety — other investors were buying T-bills. The two forces cancelled. For SVB on the right: notice the sharp drop to about negative 50 bps around day plus 5. This is the acute flight-to-safety spike — the T-bill spread compressed sharply as investors rushed out of bank deposits and into T-bills. But it recovered back to near zero by day plus 20 as markets stabilised. The final CAR is near zero, but there was a real and large transient effect. Importantly, even that transient drop is fully explained by the VIX spike and equity selloff that came with the SVB banking panic — so there is no stablecoin-specific residual. The key reading: a flat line at zero means no effect. These graphs show lines that hover near zero, occasionally dipping or rising, but without the sustained directional trend we would need to call it significant.</a:t>
             </a:r>
           </a:p>
         </p:txBody>
@@ -860,7 +860,7 @@
           <a:lstStyle/>
           <a:p>
             <a:r>
-              <a:t>This slide shows the placebo test results in table form. The placebo test is supposed to validate our methodology: run the same event study on ordinary non-crisis days and confirm the CARs are near zero. With the original inflated model we got a 21.7 times difference — which looked great but was wrong. With the corrected first-difference model, the placebo mean absolute CAR is 0.05 pp and the actual event mean absolute CAR is 0.07 pp — a ratio of only 1.5 times. They are essentially the same. This confirms that the event study, with the correct methodology, truly finds no significant effect. The next slide shows the visual comparison of the CAR paths.</a:t>
+              <a:t>This slide shows the placebo test results in table form. The placebo test is supposed to validate our methodology: run the same event study on ordinary non-crisis days and confirm the CARs are near zero. With the original inflated model we got a 21.7 times difference — which looked great but was wrong. With the corrected first-difference model, the placebo mean absolute CAR is 4.8 bps and the actual event mean absolute CAR is 7.3 bps — a ratio of only 1.5 times. They are essentially the same. This confirms that the event study, with the correct methodology, truly finds no significant effect. The next slide shows the visual comparison of the CAR paths.</a:t>
             </a:r>
           </a:p>
         </p:txBody>
@@ -930,7 +930,7 @@
           <a:lstStyle/>
           <a:p>
             <a:r>
-              <a:t>This is the visual comparison. The top row shows the placebo dates — all three hover near zero, which is exactly what we want. No event happened, no effect is measured. The bottom row shows the actual crisis events, and they also hover near zero — essentially the same as the placebos. The key observation is that you cannot visually distinguish the bottom row from the top row. For the SVB event in the bottom right, you can see the sharp transient dip to negative 0.5 pp around day 5, then a recovery. That is the acute flight-to-safety spike during the banking panic. But because it recovers, the final CAR is near zero. The dashed versus solid line style and the red versus blue colour coding show that the buffer regime and whether it is a real event or a placebo do not systematically separate the results. This confirms that the event study methodology, once corrected, cannot quantitatively identify the stablecoin buffer channel. The paper's quantitative evidence lives in the regression.</a:t>
+              <a:t>This is the visual comparison. The top row shows the placebo dates — all three hover near zero, which is exactly what we want. No event happened, no effect is measured. The bottom row shows the actual crisis events, and they also hover near zero — essentially the same as the placebos. The key observation is that you cannot visually distinguish the bottom row from the top row. For the SVB event in the bottom right, you can see the sharp transient dip to about negative 50 bps around day 5, then a recovery. That is the acute flight-to-safety spike during the banking panic. But because it recovers, the final CAR is near zero. The dashed versus solid line style and the red versus blue colour coding show that the buffer regime and whether it is a real event or a placebo do not systematically separate the results. This confirms that the event study methodology, once corrected, cannot quantitatively identify the stablecoin buffer channel. The paper's quantitative evidence lives in the regression.</a:t>
             </a:r>
           </a:p>
         </p:txBody>
@@ -1000,7 +1000,7 @@
           <a:lstStyle/>
           <a:p>
             <a:r>
-              <a:t>This slide answers the question: what does it mean to reframe the paper? In plain terms: we are not changing the conclusion. We are being honest about which evidence proves it. Before, we were pointing to the event study as the main proof — the 27 pp swing with t = 15. That was built on inflated numbers. Once corrected, the event study finds nothing significant. After, we point to two results that were always there and were never affected by the correction. First: the regression coefficient. Beta one equals negative 6.02 basis points per standard deviation of stablecoin supply. This tells us that stablecoin growth compresses the OIS-Treasury spread in normal times. That is a clean result from the monthly panel, statistically significant. Second: the Hansen threshold. The graph on the right shows what the Hansen threshold regression does. It searches over all possible values of q — the liquid buffer — and finds the one that best splits the data into two regimes. The SSR, which is the model's error, is minimised at q* = 0.130, shown by the red dashed line. That is 13 percent liquid cash. Below that threshold, the regime switches: the privilege amplification reverses. Both of these results are completely independent of the event study. They were not broken. They are the paper. The conclusion — stablecoins amplify the privilege in normal times, and the 13 percent buffer is the tipping point — is exactly the same as before. We are just being honest that the regression and threshold are what prove it, not the event study.</a:t>
+              <a:t>This slide answers the question: what does it mean to reframe the paper? In plain terms: we are not changing the conclusion. We are being honest about which evidence proves it. Before, we were pointing to the event study as the main proof — the 2,700 bps swing with t = 15. That was built on inflated numbers. Once corrected, the event study finds nothing significant. After, we point to two results that were always there and were never affected by the correction. First: the regression coefficient. Beta one equals negative 6.02 basis points per standard deviation of stablecoin supply. This tells us that stablecoin growth compresses the OIS-Treasury spread in normal times. That is a clean result from the monthly panel, statistically significant. Second: the Hansen threshold. The graph on the right shows what the Hansen threshold regression does. It searches over all possible values of q — the liquid buffer — and finds the one that best splits the data into two regimes. The SSR, which is the model's error, is minimised at q* = 0.130, shown by the red dashed line. That is 13 percent liquid cash. Below that threshold, the regime switches: the privilege amplification reverses. Both of these results are completely independent of the event study. They were not broken. They are the paper. The conclusion — stablecoins amplify the privilege in normal times, and the 13 percent buffer is the tipping point — is exactly the same as before. We are just being honest that the regression and threshold are what prove it, not the event study.</a:t>
             </a:r>
           </a:p>
         </p:txBody>
@@ -4887,7 +4887,7 @@
                 </a:solidFill>
                 <a:latin typeface="Calibri"/>
               </a:rPr>
-              <a:t>Our original event study CARs (+8.9/−18 pp) were inflated by a model specification error. We show the time series that explains what went wrong, and present the corrected numbers.</a:t>
+              <a:t>Our original event study CARs (+891/−1,801 bps) were inflated by a model specification error. We show the time series that explains what went wrong, and present the corrected numbers.</a:t>
             </a:r>
           </a:p>
         </p:txBody>
@@ -5895,7 +5895,7 @@
                 </a:solidFill>
                 <a:latin typeface="Calibri"/>
               </a:rPr>
-              <a:t>        +8.91 pp  ***</a:t>
+              <a:t>        +891 bps  ***</a:t>
             </a:r>
           </a:p>
           <a:p>
@@ -5927,7 +5927,7 @@
                 </a:solidFill>
                 <a:latin typeface="Calibri"/>
               </a:rPr>
-              <a:t>        +8.85 pp  ***</a:t>
+              <a:t>        +885 bps  ***</a:t>
             </a:r>
           </a:p>
           <a:p>
@@ -5959,7 +5959,7 @@
                 </a:solidFill>
                 <a:latin typeface="Calibri"/>
               </a:rPr>
-              <a:t>        −18.01 pp  ***</a:t>
+              <a:t>        −1,801 bps  ***</a:t>
             </a:r>
           </a:p>
         </p:txBody>
@@ -6174,7 +6174,7 @@
                 </a:solidFill>
                 <a:latin typeface="Calibri"/>
               </a:rPr>
-              <a:t>→ 34 bps/day fake 'abnormal' × 26 days = 8.84 pp</a:t>
+              <a:t>→ 34 bps/day fake 'abnormal' × 26 days = 884 bps</a:t>
             </a:r>
           </a:p>
           <a:p>
@@ -6373,7 +6373,7 @@
                 </a:solidFill>
                 <a:latin typeface="Calibri"/>
               </a:rPr>
-              <a:t>        −0.15 pp  n.s.</a:t>
+              <a:t>        −15.3 bps  n.s.</a:t>
             </a:r>
           </a:p>
           <a:p>
@@ -6405,7 +6405,7 @@
                 </a:solidFill>
                 <a:latin typeface="Calibri"/>
               </a:rPr>
-              <a:t>        −0.04 pp  n.s.</a:t>
+              <a:t>        −4.3 bps  n.s.</a:t>
             </a:r>
           </a:p>
           <a:p>
@@ -6437,7 +6437,7 @@
                 </a:solidFill>
                 <a:latin typeface="Calibri"/>
               </a:rPr>
-              <a:t>        −0.02 pp  n.s.</a:t>
+              <a:t>        −2.4 bps  n.s.</a:t>
             </a:r>
           </a:p>
           <a:p>
@@ -6925,7 +6925,7 @@
                 </a:solidFill>
                 <a:latin typeface="Calibri"/>
               </a:rPr>
-              <a:t>Original (level model):  LUNA +8.91 pp***  ·  USDT +8.85 pp***  ·  SVB −18.01 pp***</a:t>
+              <a:t>Original (level model):  LUNA +891 bps***  ·  USDT +885 bps***  ·  SVB −1,801 bps***</a:t>
             </a:r>
           </a:p>
         </p:txBody>
@@ -7003,7 +7003,7 @@
                 </a:solidFill>
                 <a:latin typeface="Calibri"/>
               </a:rPr>
-              <a:t>Corrected (first-diff model):  LUNA −0.15 pp n.s.  ·  USDT −0.04 pp n.s.  ·  SVB −0.02 pp n.s.</a:t>
+              <a:t>Corrected (first-diff model):  LUNA −15.3 bps n.s.  ·  USDT −4.3 bps n.s.  ·  SVB −2.4 bps n.s.</a:t>
             </a:r>
           </a:p>
         </p:txBody>
@@ -7513,7 +7513,7 @@
                 </a:solidFill>
                 <a:latin typeface="Calibri"/>
               </a:rPr>
-              <a:t>CAR = −0.15 pp  n.s.</a:t>
+              <a:t>CAR = −15.3 bps  n.s.</a:t>
             </a:r>
           </a:p>
         </p:txBody>
@@ -7704,7 +7704,7 @@
                 </a:solidFill>
                 <a:latin typeface="Calibri"/>
               </a:rPr>
-              <a:t>CAR = −0.04 pp  n.s.</a:t>
+              <a:t>CAR = −4.3 bps  n.s.</a:t>
             </a:r>
           </a:p>
         </p:txBody>
@@ -7895,7 +7895,7 @@
                 </a:solidFill>
                 <a:latin typeface="Calibri"/>
               </a:rPr>
-              <a:t>CAR = −0.02 pp  n.s.</a:t>
+              <a:t>CAR = −2.4 bps  n.s.</a:t>
             </a:r>
           </a:p>
         </p:txBody>
@@ -8086,7 +8086,7 @@
                 </a:solidFill>
                 <a:latin typeface="Calibri"/>
               </a:rPr>
-              <a:t>Dashed vertical line = event date (τ = 0).  Y-axis = cumulative abnormal spread change in pp since 5 days before the event.  A flat line at zero means the event had no measurable effect on the spread.</a:t>
+              <a:t>Dashed vertical line = event date (τ = 0).  Y-axis = cumulative abnormal spread change in bps since 5 days before the event.  A flat line at zero means the event had no measurable effect on the spread.</a:t>
             </a:r>
           </a:p>
         </p:txBody>
@@ -8164,7 +8164,7 @@
                 </a:solidFill>
                 <a:latin typeface="Calibri"/>
               </a:rPr>
-              <a:t>Note on SVB (right panel): the CAR drops sharply to −0.5 pp around day +5 (the flight-to-safety spike), then recovers. Final CAR at day +20 is near zero because the spread normalised as markets calmed. The transient drop is real but fully explained by the VIX/equity controls.</a:t>
+              <a:t>Note on SVB (right panel): the CAR drops sharply to ~−50 bps around day +5 (the flight-to-safety spike), then recovers. Final CAR at day +20 is near zero because the spread normalised as markets calmed. The transient drop is real but fully explained by the VIX/equity controls.</a:t>
             </a:r>
           </a:p>
         </p:txBody>
@@ -8806,7 +8806,7 @@
                 </a:solidFill>
                 <a:latin typeface="Calibri"/>
               </a:rPr>
-              <a:t>CAR (pp)</a:t>
+              <a:t>CAR (bps)</a:t>
             </a:r>
           </a:p>
         </p:txBody>
@@ -9352,7 +9352,7 @@
                 </a:solidFill>
                 <a:latin typeface="Calibri"/>
               </a:rPr>
-              <a:t>+0.01</a:t>
+              <a:t>+1.39</a:t>
             </a:r>
           </a:p>
         </p:txBody>
@@ -9898,7 +9898,7 @@
                 </a:solidFill>
                 <a:latin typeface="Calibri"/>
               </a:rPr>
-              <a:t>+0.02</a:t>
+              <a:t>+1.97</a:t>
             </a:r>
           </a:p>
         </p:txBody>
@@ -10444,7 +10444,7 @@
                 </a:solidFill>
                 <a:latin typeface="Calibri"/>
               </a:rPr>
-              <a:t>−0.11</a:t>
+              <a:t>−10.99</a:t>
             </a:r>
           </a:p>
         </p:txBody>
@@ -10990,7 +10990,7 @@
                 </a:solidFill>
                 <a:latin typeface="Calibri"/>
               </a:rPr>
-              <a:t>−0.15</a:t>
+              <a:t>−15.25</a:t>
             </a:r>
           </a:p>
         </p:txBody>
@@ -11536,7 +11536,7 @@
                 </a:solidFill>
                 <a:latin typeface="Calibri"/>
               </a:rPr>
-              <a:t>−0.04</a:t>
+              <a:t>−4.27</a:t>
             </a:r>
           </a:p>
         </p:txBody>
@@ -12082,7 +12082,7 @@
                 </a:solidFill>
                 <a:latin typeface="Calibri"/>
               </a:rPr>
-              <a:t>−0.02</a:t>
+              <a:t>−2.35</a:t>
             </a:r>
           </a:p>
         </p:txBody>
@@ -12394,7 +12394,7 @@
                 </a:solidFill>
                 <a:latin typeface="Calibri"/>
               </a:rPr>
-              <a:t>Placebo mean |CAR| = 0.05 pp          Actual mean |CAR| = 0.07 pp          Ratio = 1.5×          (original inflated ratio was 21.7×)</a:t>
+              <a:t>Placebo mean |CAR| = 4.8 bps          Actual mean |CAR| = 7.3 bps          Ratio = 1.5×          (original inflated ratio was 21.7×)</a:t>
             </a:r>
           </a:p>
         </p:txBody>
@@ -13904,7 +13904,7 @@
                 </a:solidFill>
                 <a:latin typeface="Calibri"/>
               </a:rPr>
-              <a:t>"The event study shows +8.9/−18 pp CARs."</a:t>
+              <a:t>"The event study shows +891/−1,801 bps CARs."</a:t>
             </a:r>
           </a:p>
           <a:p>
@@ -13920,7 +13920,7 @@
                 </a:solidFill>
                 <a:latin typeface="Calibri"/>
               </a:rPr>
-              <a:t>"A 27 pp swing with Welch t = 15.22."</a:t>
+              <a:t>"A 2,700 bps swing with Welch t = 15.22."</a:t>
             </a:r>
           </a:p>
           <a:p>
@@ -13984,7 +13984,7 @@
                 </a:solidFill>
                 <a:latin typeface="Calibri"/>
               </a:rPr>
-              <a:t>Corrected CARs: near zero. The '27 pp swing' disappears.</a:t>
+              <a:t>Corrected CARs: near zero. The '2,700 bps swing' disappears.</a:t>
             </a:r>
           </a:p>
         </p:txBody>

</xml_diff>

<commit_message>
added Minjin in the cover and last page
</commit_message>
<xml_diff>
--- a/presentations/0602_Stablecoin_Exorbitant_Privilege.pptx
+++ b/presentations/0602_Stablecoin_Exorbitant_Privilege.pptx
@@ -8,13 +8,13 @@
     <p:notesMasterId r:id="rId9"/>
   </p:notesMasterIdLst>
   <p:sldIdLst>
-    <p:sldId id="256" r:id="rId2"/>
+    <p:sldId id="266" r:id="rId2"/>
     <p:sldId id="257" r:id="rId3"/>
     <p:sldId id="258" r:id="rId4"/>
     <p:sldId id="259" r:id="rId5"/>
     <p:sldId id="260" r:id="rId6"/>
     <p:sldId id="261" r:id="rId7"/>
-    <p:sldId id="262" r:id="rId8"/>
+    <p:sldId id="267" r:id="rId8"/>
   </p:sldIdLst>
   <p:sldSz cx="12188825" cy="6858000"/>
   <p:notesSz cx="6858000" cy="9144000"/>
@@ -302,7 +302,7 @@
           <a:lstStyle/>
           <a:p>
             <a:r>
-              <a:t>Good afternoon. Since last week's presentation we have three updates. First: we corrected and retested the event study — the CARs are insignificant. Second: we ran two robustness checks on the 13% buffer threshold — TRIM sensitivity and a Smooth Transition Regression. Both independently confirm q* is near 13%. The main finding of the paper — β₁ = −6.02 bps and q* = 13% — stands.</a:t>
+              <a:t>Good afternoon everyone. Our paper is called Stablecoins and the Exorbitant Privilege. The central argument is that large USD-pegged stablecoin issuers — mainly Tether and Circle — have become significant buyers of U.S. Treasury bills. In normal times, that deepens demand for safe assets and amplifies America's borrowing advantage. But when a run hits and their cash reserves are too thin, they are forced to liquidate T-bills, which rapidly reverses that benefit. Today we want to address some methodological questions from last session and walk clearly through our three stress events.</a:t>
             </a:r>
           </a:p>
         </p:txBody>
@@ -11891,7 +11891,7 @@
           <a:lstStyle/>
           <a:p>
             <a:r>
-              <a:t>Thank you. Three sentences to close. First: stablecoin issuers are now structurally important buyers of US Treasury bills. Each standard deviation of supply growth compresses the OIS-Treasury spread by 6 basis points — deepening the exorbitant privilege. Second: this amplification reverses when the issuer's liquid cash buffer falls below 13%. Third: two independent threshold models — Hansen's sharp switch and our LSTAR smooth transition — both locate this tipping point at 13%. We are happy to take questions.</a:t>
+              <a:t>Thank you for your time. Our paper makes two main contributions. First: stablecoin issuers have become structurally important buyers of U.S. Treasury bills. Each standard deviation increase in stablecoin supply compresses the OIS-Treasury spread by 6 basis points — that is the exorbitant privilege amplification we identify. Second: this relationship is conditional on the liquid buffer. The Hansen threshold regression identifies 13 percent as the critical cash reserve ratio. Above it, issuers absorb redemption shocks without touching T-bills. Below it, redemption pressure forces T-bill sales that reverse the privilege. We acknowledge that our event study, originally designed to dramatize these regimes, required methodological correction — our original level model inflated the CARs by attributing the 2022 Fed hiking trend as abnormal. With the corrected first-difference model, the event study provides qualitative directional support but not strong quantitative evidence. The paper's core identification rests on the panel regression and the threshold estimate. We are happy to take any questions.</a:t>
             </a:r>
           </a:p>
         </p:txBody>
@@ -12095,7 +12095,7 @@
           <a:p>
             <a:fld id="{5BCAD085-E8A6-8845-BD4E-CB4CCA059FC4}" type="datetimeFigureOut">
               <a:rPr lang="en-US" smtClean="0"/>
-              <a:t>6/1/2026</a:t>
+              <a:t>6/2/26</a:t>
             </a:fld>
             <a:endParaRPr lang="en-US"/>
           </a:p>
@@ -12263,7 +12263,7 @@
           <a:p>
             <a:fld id="{5BCAD085-E8A6-8845-BD4E-CB4CCA059FC4}" type="datetimeFigureOut">
               <a:rPr lang="en-US" smtClean="0"/>
-              <a:t>6/1/2026</a:t>
+              <a:t>6/2/26</a:t>
             </a:fld>
             <a:endParaRPr lang="en-US"/>
           </a:p>
@@ -12441,7 +12441,7 @@
           <a:p>
             <a:fld id="{5BCAD085-E8A6-8845-BD4E-CB4CCA059FC4}" type="datetimeFigureOut">
               <a:rPr lang="en-US" smtClean="0"/>
-              <a:t>6/1/2026</a:t>
+              <a:t>6/2/26</a:t>
             </a:fld>
             <a:endParaRPr lang="en-US"/>
           </a:p>
@@ -12609,7 +12609,7 @@
           <a:p>
             <a:fld id="{5BCAD085-E8A6-8845-BD4E-CB4CCA059FC4}" type="datetimeFigureOut">
               <a:rPr lang="en-US" smtClean="0"/>
-              <a:t>6/1/2026</a:t>
+              <a:t>6/2/26</a:t>
             </a:fld>
             <a:endParaRPr lang="en-US"/>
           </a:p>
@@ -12854,7 +12854,7 @@
           <a:p>
             <a:fld id="{5BCAD085-E8A6-8845-BD4E-CB4CCA059FC4}" type="datetimeFigureOut">
               <a:rPr lang="en-US" smtClean="0"/>
-              <a:t>6/1/2026</a:t>
+              <a:t>6/2/26</a:t>
             </a:fld>
             <a:endParaRPr lang="en-US"/>
           </a:p>
@@ -13139,7 +13139,7 @@
           <a:p>
             <a:fld id="{5BCAD085-E8A6-8845-BD4E-CB4CCA059FC4}" type="datetimeFigureOut">
               <a:rPr lang="en-US" smtClean="0"/>
-              <a:t>6/1/2026</a:t>
+              <a:t>6/2/26</a:t>
             </a:fld>
             <a:endParaRPr lang="en-US"/>
           </a:p>
@@ -13558,7 +13558,7 @@
           <a:p>
             <a:fld id="{5BCAD085-E8A6-8845-BD4E-CB4CCA059FC4}" type="datetimeFigureOut">
               <a:rPr lang="en-US" smtClean="0"/>
-              <a:t>6/1/2026</a:t>
+              <a:t>6/2/26</a:t>
             </a:fld>
             <a:endParaRPr lang="en-US"/>
           </a:p>
@@ -13675,7 +13675,7 @@
           <a:p>
             <a:fld id="{5BCAD085-E8A6-8845-BD4E-CB4CCA059FC4}" type="datetimeFigureOut">
               <a:rPr lang="en-US" smtClean="0"/>
-              <a:t>6/1/2026</a:t>
+              <a:t>6/2/26</a:t>
             </a:fld>
             <a:endParaRPr lang="en-US"/>
           </a:p>
@@ -13770,7 +13770,7 @@
           <a:p>
             <a:fld id="{5BCAD085-E8A6-8845-BD4E-CB4CCA059FC4}" type="datetimeFigureOut">
               <a:rPr lang="en-US" smtClean="0"/>
-              <a:t>6/1/2026</a:t>
+              <a:t>6/2/26</a:t>
             </a:fld>
             <a:endParaRPr lang="en-US"/>
           </a:p>
@@ -14045,7 +14045,7 @@
           <a:p>
             <a:fld id="{5BCAD085-E8A6-8845-BD4E-CB4CCA059FC4}" type="datetimeFigureOut">
               <a:rPr lang="en-US" smtClean="0"/>
-              <a:t>6/1/2026</a:t>
+              <a:t>6/2/26</a:t>
             </a:fld>
             <a:endParaRPr lang="en-US"/>
           </a:p>
@@ -14297,7 +14297,7 @@
           <a:p>
             <a:fld id="{5BCAD085-E8A6-8845-BD4E-CB4CCA059FC4}" type="datetimeFigureOut">
               <a:rPr lang="en-US" smtClean="0"/>
-              <a:t>6/1/2026</a:t>
+              <a:t>6/2/26</a:t>
             </a:fld>
             <a:endParaRPr lang="en-US"/>
           </a:p>
@@ -14508,7 +14508,7 @@
           <a:p>
             <a:fld id="{5BCAD085-E8A6-8845-BD4E-CB4CCA059FC4}" type="datetimeFigureOut">
               <a:rPr lang="en-US" smtClean="0"/>
-              <a:t>6/1/2026</a:t>
+              <a:t>6/2/26</a:t>
             </a:fld>
             <a:endParaRPr lang="en-US"/>
           </a:p>
@@ -14869,6 +14869,14 @@
 <file path=ppt/slides/slide1.xml><?xml version="1.0" encoding="utf-8"?>
 <p:sld xmlns:a="http://schemas.openxmlformats.org/drawingml/2006/main" xmlns:r="http://schemas.openxmlformats.org/officeDocument/2006/relationships" xmlns:p="http://schemas.openxmlformats.org/presentationml/2006/main">
   <p:cSld>
+    <p:bg>
+      <p:bgPr>
+        <a:solidFill>
+          <a:srgbClr val="002060"/>
+        </a:solidFill>
+        <a:effectLst/>
+      </p:bgPr>
+    </p:bg>
     <p:spTree>
       <p:nvGrpSpPr>
         <p:cNvPr id="1" name=""/>
@@ -14883,35 +14891,79 @@
           <a:chExt cx="0" cy="0"/>
         </a:xfrm>
       </p:grpSpPr>
-      <p:sp>
-        <p:nvSpPr>
-          <p:cNvPr id="2" name="Rectangle 1"/>
+      <p:pic>
+        <p:nvPicPr>
+          <p:cNvPr id="3" name="그림 2" descr="원, 그래픽, 스크린샷, 그래픽 디자인이(가) 표시된 사진&#10;&#10;자동 생성된 설명"/>
+          <p:cNvPicPr>
+            <a:picLocks noChangeAspect="1"/>
+          </p:cNvPicPr>
+          <p:nvPr/>
+        </p:nvPicPr>
+        <p:blipFill>
+          <a:blip r:embed="rId3">
+            <a:lum bright="70000" contrast="-70000"/>
+            <a:extLst>
+              <a:ext uri="{BEBA8EAE-BF5A-486C-A8C5-ECC9F3942E4B}">
+                <a14:imgProps xmlns:a14="http://schemas.microsoft.com/office/drawing/2010/main">
+                  <a14:imgLayer r:embed="rId4">
+                    <a14:imgEffect>
+                      <a14:artisticPhotocopy detail="2"/>
+                    </a14:imgEffect>
+                  </a14:imgLayer>
+                </a14:imgProps>
+              </a:ext>
+              <a:ext uri="{28A0092B-C50C-407E-A947-70E740481C1C}">
+                <a14:useLocalDpi xmlns:a14="http://schemas.microsoft.com/office/drawing/2010/main" val="0"/>
+              </a:ext>
+            </a:extLst>
+          </a:blip>
+          <a:stretch>
+            <a:fillRect/>
+          </a:stretch>
+        </p:blipFill>
+        <p:spPr>
+          <a:xfrm>
+            <a:off x="0" y="890"/>
+            <a:ext cx="4809898" cy="6856214"/>
+          </a:xfrm>
+          <a:prstGeom prst="rect">
+            <a:avLst/>
+          </a:prstGeom>
+        </p:spPr>
+      </p:pic>
+      <p:sp>
+        <p:nvSpPr>
+          <p:cNvPr id="6" name="직사각형 5"/>
           <p:cNvSpPr/>
           <p:nvPr/>
         </p:nvSpPr>
         <p:spPr>
           <a:xfrm>
-            <a:off x="0" y="0"/>
-            <a:ext cx="12188952" cy="6858000"/>
+            <a:off x="-1" y="1879560"/>
+            <a:ext cx="12188826" cy="2576274"/>
           </a:xfrm>
           <a:prstGeom prst="rect">
             <a:avLst/>
           </a:prstGeom>
           <a:solidFill>
-            <a:srgbClr val="0A1E5C"/>
+            <a:schemeClr val="tx1">
+              <a:alpha val="55000"/>
+            </a:schemeClr>
           </a:solidFill>
           <a:ln>
             <a:noFill/>
           </a:ln>
         </p:spPr>
         <p:style>
-          <a:lnRef idx="1">
-            <a:schemeClr val="accent1"/>
+          <a:lnRef idx="2">
+            <a:schemeClr val="accent1">
+              <a:shade val="15000"/>
+            </a:schemeClr>
           </a:lnRef>
-          <a:fillRef idx="3">
+          <a:fillRef idx="1">
             <a:schemeClr val="accent1"/>
           </a:fillRef>
-          <a:effectRef idx="2">
+          <a:effectRef idx="0">
             <a:schemeClr val="accent1"/>
           </a:effectRef>
           <a:fontRef idx="minor">
@@ -14922,285 +14974,44 @@
           <a:bodyPr rtlCol="0" anchor="ctr"/>
           <a:lstStyle/>
           <a:p>
-            <a:pPr algn="ctr"/>
-            <a:endParaRPr/>
+            <a:pPr algn="ctr" defTabSz="914400" latinLnBrk="1">
+              <a:defRPr/>
+            </a:pPr>
+            <a:r>
+              <a:rPr lang="en-US" altLang="ko-KR" sz="2400" dirty="0">
+                <a:solidFill>
+                  <a:prstClr val="white"/>
+                </a:solidFill>
+                <a:latin typeface="Hiragino Kaku Gothic Std W8" panose="020B0800000000000000" pitchFamily="34" charset="-128"/>
+                <a:ea typeface="Hiragino Kaku Gothic Std W8" panose="020B0800000000000000" pitchFamily="34" charset="-128"/>
+              </a:rPr>
+              <a:t>STABLECOINS AND THE EXORBITANT PRIVILEGE</a:t>
+            </a:r>
+          </a:p>
+          <a:p>
+            <a:pPr algn="ctr" defTabSz="914400" latinLnBrk="1">
+              <a:defRPr/>
+            </a:pPr>
+            <a:endParaRPr lang="ko-KR" altLang="en-US" sz="2400" dirty="0">
+              <a:solidFill>
+                <a:prstClr val="white"/>
+              </a:solidFill>
+              <a:latin typeface="Hiragino Kaku Gothic Std W8" panose="020B0800000000000000" pitchFamily="34" charset="-128"/>
+              <a:ea typeface="Malgun Gothic" panose="020B0503020000020004" pitchFamily="50" charset="-127"/>
+            </a:endParaRPr>
           </a:p>
         </p:txBody>
       </p:sp>
       <p:sp>
         <p:nvSpPr>
-          <p:cNvPr id="3" name="Rectangle 2"/>
-          <p:cNvSpPr/>
+          <p:cNvPr id="11" name="TextBox 10"/>
+          <p:cNvSpPr txBox="1"/>
           <p:nvPr/>
         </p:nvSpPr>
         <p:spPr>
           <a:xfrm>
-            <a:off x="0" y="2606040"/>
-            <a:ext cx="12188952" cy="1051560"/>
-          </a:xfrm>
-          <a:prstGeom prst="rect">
-            <a:avLst/>
-          </a:prstGeom>
-          <a:solidFill>
-            <a:srgbClr val="143070"/>
-          </a:solidFill>
-          <a:ln>
-            <a:noFill/>
-          </a:ln>
-        </p:spPr>
-        <p:style>
-          <a:lnRef idx="1">
-            <a:schemeClr val="accent1"/>
-          </a:lnRef>
-          <a:fillRef idx="3">
-            <a:schemeClr val="accent1"/>
-          </a:fillRef>
-          <a:effectRef idx="2">
-            <a:schemeClr val="accent1"/>
-          </a:effectRef>
-          <a:fontRef idx="minor">
-            <a:schemeClr val="lt1"/>
-          </a:fontRef>
-        </p:style>
-        <p:txBody>
-          <a:bodyPr rtlCol="0" anchor="ctr"/>
-          <a:lstStyle/>
-          <a:p>
-            <a:pPr algn="ctr"/>
-            <a:endParaRPr/>
-          </a:p>
-        </p:txBody>
-      </p:sp>
-      <p:sp>
-        <p:nvSpPr>
-          <p:cNvPr id="4" name="Oval 3"/>
-          <p:cNvSpPr/>
-          <p:nvPr/>
-        </p:nvSpPr>
-        <p:spPr>
-          <a:xfrm>
-            <a:off x="91440" y="0"/>
-            <a:ext cx="3474720" cy="3474720"/>
-          </a:xfrm>
-          <a:prstGeom prst="ellipse">
-            <a:avLst/>
-          </a:prstGeom>
-          <a:solidFill>
-            <a:srgbClr val="FFFFFF"/>
-          </a:solidFill>
-          <a:ln>
-            <a:noFill/>
-          </a:ln>
-        </p:spPr>
-        <p:style>
-          <a:lnRef idx="1">
-            <a:schemeClr val="accent1"/>
-          </a:lnRef>
-          <a:fillRef idx="3">
-            <a:schemeClr val="accent1"/>
-          </a:fillRef>
-          <a:effectRef idx="2">
-            <a:schemeClr val="accent1"/>
-          </a:effectRef>
-          <a:fontRef idx="minor">
-            <a:schemeClr val="lt1"/>
-          </a:fontRef>
-        </p:style>
-        <p:txBody>
-          <a:bodyPr rtlCol="0" anchor="ctr"/>
-          <a:lstStyle/>
-          <a:p>
-            <a:pPr algn="ctr"/>
-            <a:endParaRPr/>
-          </a:p>
-        </p:txBody>
-      </p:sp>
-      <p:sp>
-        <p:nvSpPr>
-          <p:cNvPr id="5" name="Oval 4"/>
-          <p:cNvSpPr/>
-          <p:nvPr/>
-        </p:nvSpPr>
-        <p:spPr>
-          <a:xfrm>
-            <a:off x="502920" y="411480"/>
-            <a:ext cx="2651760" cy="2651760"/>
-          </a:xfrm>
-          <a:prstGeom prst="ellipse">
-            <a:avLst/>
-          </a:prstGeom>
-          <a:solidFill>
-            <a:srgbClr val="0A1E5C"/>
-          </a:solidFill>
-          <a:ln>
-            <a:noFill/>
-          </a:ln>
-        </p:spPr>
-        <p:style>
-          <a:lnRef idx="1">
-            <a:schemeClr val="accent1"/>
-          </a:lnRef>
-          <a:fillRef idx="3">
-            <a:schemeClr val="accent1"/>
-          </a:fillRef>
-          <a:effectRef idx="2">
-            <a:schemeClr val="accent1"/>
-          </a:effectRef>
-          <a:fontRef idx="minor">
-            <a:schemeClr val="lt1"/>
-          </a:fontRef>
-        </p:style>
-        <p:txBody>
-          <a:bodyPr rtlCol="0" anchor="ctr"/>
-          <a:lstStyle/>
-          <a:p>
-            <a:pPr algn="ctr"/>
-            <a:endParaRPr/>
-          </a:p>
-        </p:txBody>
-      </p:sp>
-      <p:sp>
-        <p:nvSpPr>
-          <p:cNvPr id="6" name="Oval 5"/>
-          <p:cNvSpPr/>
-          <p:nvPr/>
-        </p:nvSpPr>
-        <p:spPr>
-          <a:xfrm>
-            <a:off x="91440" y="4023360"/>
-            <a:ext cx="3291840" cy="3291840"/>
-          </a:xfrm>
-          <a:prstGeom prst="ellipse">
-            <a:avLst/>
-          </a:prstGeom>
-          <a:solidFill>
-            <a:srgbClr val="FFFFFF"/>
-          </a:solidFill>
-          <a:ln>
-            <a:noFill/>
-          </a:ln>
-        </p:spPr>
-        <p:style>
-          <a:lnRef idx="1">
-            <a:schemeClr val="accent1"/>
-          </a:lnRef>
-          <a:fillRef idx="3">
-            <a:schemeClr val="accent1"/>
-          </a:fillRef>
-          <a:effectRef idx="2">
-            <a:schemeClr val="accent1"/>
-          </a:effectRef>
-          <a:fontRef idx="minor">
-            <a:schemeClr val="lt1"/>
-          </a:fontRef>
-        </p:style>
-        <p:txBody>
-          <a:bodyPr rtlCol="0" anchor="ctr"/>
-          <a:lstStyle/>
-          <a:p>
-            <a:pPr algn="ctr"/>
-            <a:endParaRPr/>
-          </a:p>
-        </p:txBody>
-      </p:sp>
-      <p:sp>
-        <p:nvSpPr>
-          <p:cNvPr id="7" name="Oval 6"/>
-          <p:cNvSpPr/>
-          <p:nvPr/>
-        </p:nvSpPr>
-        <p:spPr>
-          <a:xfrm>
-            <a:off x="594360" y="4434840"/>
-            <a:ext cx="2286000" cy="2286000"/>
-          </a:xfrm>
-          <a:prstGeom prst="ellipse">
-            <a:avLst/>
-          </a:prstGeom>
-          <a:solidFill>
-            <a:srgbClr val="0A1E5C"/>
-          </a:solidFill>
-          <a:ln>
-            <a:noFill/>
-          </a:ln>
-        </p:spPr>
-        <p:style>
-          <a:lnRef idx="1">
-            <a:schemeClr val="accent1"/>
-          </a:lnRef>
-          <a:fillRef idx="3">
-            <a:schemeClr val="accent1"/>
-          </a:fillRef>
-          <a:effectRef idx="2">
-            <a:schemeClr val="accent1"/>
-          </a:effectRef>
-          <a:fontRef idx="minor">
-            <a:schemeClr val="lt1"/>
-          </a:fontRef>
-        </p:style>
-        <p:txBody>
-          <a:bodyPr rtlCol="0" anchor="ctr"/>
-          <a:lstStyle/>
-          <a:p>
-            <a:pPr algn="ctr"/>
-            <a:endParaRPr/>
-          </a:p>
-        </p:txBody>
-      </p:sp>
-      <p:sp>
-        <p:nvSpPr>
-          <p:cNvPr id="8" name="Rectangle 7"/>
-          <p:cNvSpPr/>
-          <p:nvPr/>
-        </p:nvSpPr>
-        <p:spPr>
-          <a:xfrm>
-            <a:off x="0" y="2331720"/>
-            <a:ext cx="3474720" cy="548640"/>
-          </a:xfrm>
-          <a:prstGeom prst="rect">
-            <a:avLst/>
-          </a:prstGeom>
-          <a:solidFill>
-            <a:srgbClr val="555566"/>
-          </a:solidFill>
-          <a:ln>
-            <a:noFill/>
-          </a:ln>
-        </p:spPr>
-        <p:style>
-          <a:lnRef idx="1">
-            <a:schemeClr val="accent1"/>
-          </a:lnRef>
-          <a:fillRef idx="3">
-            <a:schemeClr val="accent1"/>
-          </a:fillRef>
-          <a:effectRef idx="2">
-            <a:schemeClr val="accent1"/>
-          </a:effectRef>
-          <a:fontRef idx="minor">
-            <a:schemeClr val="lt1"/>
-          </a:fontRef>
-        </p:style>
-        <p:txBody>
-          <a:bodyPr rtlCol="0" anchor="ctr"/>
-          <a:lstStyle/>
-          <a:p>
-            <a:pPr algn="ctr"/>
-            <a:endParaRPr/>
-          </a:p>
-        </p:txBody>
-      </p:sp>
-      <p:sp>
-        <p:nvSpPr>
-          <p:cNvPr id="9" name="TextBox 8"/>
-          <p:cNvSpPr txBox="1"/>
-          <p:nvPr/>
-        </p:nvSpPr>
-        <p:spPr>
-          <a:xfrm>
-            <a:off x="3657600" y="2423160"/>
-            <a:ext cx="8229600" cy="594360"/>
+            <a:off x="6094095" y="5560060"/>
+            <a:ext cx="5842635" cy="1200329"/>
           </a:xfrm>
           <a:prstGeom prst="rect">
             <a:avLst/>
@@ -15208,137 +15019,65 @@
           <a:noFill/>
         </p:spPr>
         <p:txBody>
-          <a:bodyPr wrap="square">
+          <a:bodyPr wrap="square" rtlCol="0">
             <a:spAutoFit/>
           </a:bodyPr>
           <a:lstStyle/>
           <a:p>
-            <a:pPr algn="l"/>
-            <a:r>
-              <a:rPr sz="2200" b="0" i="0">
+            <a:r>
+              <a:rPr lang="en-US" altLang="ko-KR" sz="1800" b="1" dirty="0">
+                <a:solidFill>
+                  <a:schemeClr val="bg1"/>
+                </a:solidFill>
+              </a:rPr>
+              <a:t>Yonsei GSIS 2026-1 </a:t>
+            </a:r>
+          </a:p>
+          <a:p>
+            <a:r>
+              <a:rPr lang="en-US" altLang="ko-KR" sz="1800" b="1" dirty="0">
+                <a:solidFill>
+                  <a:schemeClr val="bg1"/>
+                </a:solidFill>
+              </a:rPr>
+              <a:t>Topics in International Finance</a:t>
+            </a:r>
+            <a:endParaRPr lang="en-US" altLang="ko-KR" sz="1800" dirty="0">
+              <a:solidFill>
+                <a:schemeClr val="bg1"/>
+              </a:solidFill>
+            </a:endParaRPr>
+          </a:p>
+          <a:p>
+            <a:r>
+              <a:rPr lang="en-US" altLang="ko-KR" b="1" dirty="0">
                 <a:solidFill>
                   <a:srgbClr val="FFFFFF"/>
                 </a:solidFill>
-                <a:latin typeface="Calibri Light"/>
-              </a:rPr>
-              <a:t>STABLECOINS AND THE EXORBITANT PRIVILEGE</a:t>
-            </a:r>
-          </a:p>
-        </p:txBody>
-      </p:sp>
-      <p:sp>
-        <p:nvSpPr>
-          <p:cNvPr id="10" name="TextBox 9"/>
-          <p:cNvSpPr txBox="1"/>
-          <p:nvPr/>
-        </p:nvSpPr>
-        <p:spPr>
-          <a:xfrm>
-            <a:off x="3657600" y="3017520"/>
-            <a:ext cx="8229600" cy="457200"/>
-          </a:xfrm>
-          <a:prstGeom prst="rect">
-            <a:avLst/>
-          </a:prstGeom>
-          <a:noFill/>
-        </p:spPr>
-        <p:txBody>
-          <a:bodyPr wrap="square">
-            <a:spAutoFit/>
-          </a:bodyPr>
-          <a:lstStyle/>
-          <a:p>
-            <a:pPr algn="l"/>
-            <a:r>
-              <a:rPr sz="1300" b="0" i="1">
-                <a:solidFill>
-                  <a:srgbClr val="AAC4E8"/>
-                </a:solidFill>
-                <a:latin typeface="Calibri"/>
-              </a:rPr>
-              <a:t>Event Study Update  ·  Threshold Robustness  ·  LSTAR Validation</a:t>
-            </a:r>
-          </a:p>
-        </p:txBody>
-      </p:sp>
-      <p:sp>
-        <p:nvSpPr>
-          <p:cNvPr id="11" name="Rectangle 10"/>
-          <p:cNvSpPr/>
-          <p:nvPr/>
-        </p:nvSpPr>
-        <p:spPr>
-          <a:xfrm>
-            <a:off x="3566160" y="4069080"/>
-            <a:ext cx="6858000" cy="2560320"/>
-          </a:xfrm>
-          <a:prstGeom prst="rect">
-            <a:avLst/>
-          </a:prstGeom>
-          <a:solidFill>
-            <a:srgbClr val="0E2668"/>
-          </a:solidFill>
-          <a:ln>
-            <a:noFill/>
-          </a:ln>
-        </p:spPr>
-        <p:style>
-          <a:lnRef idx="1">
-            <a:schemeClr val="accent1"/>
-          </a:lnRef>
-          <a:fillRef idx="3">
-            <a:schemeClr val="accent1"/>
-          </a:fillRef>
-          <a:effectRef idx="2">
-            <a:schemeClr val="accent1"/>
-          </a:effectRef>
-          <a:fontRef idx="minor">
-            <a:schemeClr val="lt1"/>
-          </a:fontRef>
-        </p:style>
-        <p:txBody>
-          <a:bodyPr rtlCol="0" anchor="ctr"/>
-          <a:lstStyle/>
-          <a:p>
-            <a:pPr algn="ctr"/>
-            <a:endParaRPr/>
-          </a:p>
-        </p:txBody>
-      </p:sp>
-      <p:sp>
-        <p:nvSpPr>
-          <p:cNvPr id="12" name="TextBox 11"/>
-          <p:cNvSpPr txBox="1"/>
-          <p:nvPr/>
-        </p:nvSpPr>
-        <p:spPr>
-          <a:xfrm>
-            <a:off x="3749039" y="4206240"/>
-            <a:ext cx="6583680" cy="2286000"/>
-          </a:xfrm>
-          <a:prstGeom prst="rect">
-            <a:avLst/>
-          </a:prstGeom>
-          <a:noFill/>
-        </p:spPr>
-        <p:txBody>
-          <a:bodyPr wrap="square">
-            <a:spAutoFit/>
-          </a:bodyPr>
-          <a:lstStyle/>
-          <a:p>
-            <a:pPr algn="l"/>
-            <a:r>
-              <a:rPr sz="1600" b="0" i="0">
+              </a:rPr>
+              <a:t>Mireu Kim · Sara Chekroune · Oybek Ibragimov · Jade Zhu  Alexandre Godefroy · Baptiste Degand · </a:t>
+            </a:r>
+            <a:r>
+              <a:rPr lang="en-US" altLang="ko-KR" b="1" dirty="0" err="1">
                 <a:solidFill>
                   <a:srgbClr val="FFFFFF"/>
                 </a:solidFill>
-                <a:latin typeface="Calibri"/>
-              </a:rPr>
-              <a:t>Yonsei GSIS 2026-1  |  Topics in International Finance
-Mireu Kim · Sara Chekroune · Oybek Ibragimov
-June 2026</a:t>
-            </a:r>
+              </a:rPr>
+              <a:t>Minjin</a:t>
+            </a:r>
+            <a:r>
+              <a:rPr lang="en-US" altLang="ko-KR" b="1" dirty="0">
+                <a:solidFill>
+                  <a:srgbClr val="FFFFFF"/>
+                </a:solidFill>
+              </a:rPr>
+              <a:t> Kim </a:t>
+            </a:r>
+            <a:endParaRPr lang="en-US" altLang="ko-KR" sz="1800" b="1" dirty="0">
+              <a:solidFill>
+                <a:srgbClr val="FFFFFF"/>
+              </a:solidFill>
+            </a:endParaRPr>
           </a:p>
         </p:txBody>
       </p:sp>
@@ -21730,6 +21469,14 @@
 <file path=ppt/slides/slide7.xml><?xml version="1.0" encoding="utf-8"?>
 <p:sld xmlns:a="http://schemas.openxmlformats.org/drawingml/2006/main" xmlns:r="http://schemas.openxmlformats.org/officeDocument/2006/relationships" xmlns:p="http://schemas.openxmlformats.org/presentationml/2006/main">
   <p:cSld>
+    <p:bg>
+      <p:bgPr>
+        <a:solidFill>
+          <a:srgbClr val="002060"/>
+        </a:solidFill>
+        <a:effectLst/>
+      </p:bgPr>
+    </p:bg>
     <p:spTree>
       <p:nvGrpSpPr>
         <p:cNvPr id="1" name=""/>
@@ -21744,35 +21491,79 @@
           <a:chExt cx="0" cy="0"/>
         </a:xfrm>
       </p:grpSpPr>
-      <p:sp>
-        <p:nvSpPr>
-          <p:cNvPr id="2" name="Rectangle 1"/>
+      <p:pic>
+        <p:nvPicPr>
+          <p:cNvPr id="3" name="그림 2" descr="원, 그래픽, 스크린샷, 그래픽 디자인이(가) 표시된 사진&#10;&#10;자동 생성된 설명"/>
+          <p:cNvPicPr>
+            <a:picLocks noChangeAspect="1"/>
+          </p:cNvPicPr>
+          <p:nvPr/>
+        </p:nvPicPr>
+        <p:blipFill>
+          <a:blip r:embed="rId3">
+            <a:lum bright="70000" contrast="-70000"/>
+            <a:extLst>
+              <a:ext uri="{BEBA8EAE-BF5A-486C-A8C5-ECC9F3942E4B}">
+                <a14:imgProps xmlns:a14="http://schemas.microsoft.com/office/drawing/2010/main">
+                  <a14:imgLayer r:embed="rId4">
+                    <a14:imgEffect>
+                      <a14:artisticPhotocopy detail="2"/>
+                    </a14:imgEffect>
+                  </a14:imgLayer>
+                </a14:imgProps>
+              </a:ext>
+              <a:ext uri="{28A0092B-C50C-407E-A947-70E740481C1C}">
+                <a14:useLocalDpi xmlns:a14="http://schemas.microsoft.com/office/drawing/2010/main" val="0"/>
+              </a:ext>
+            </a:extLst>
+          </a:blip>
+          <a:stretch>
+            <a:fillRect/>
+          </a:stretch>
+        </p:blipFill>
+        <p:spPr>
+          <a:xfrm>
+            <a:off x="0" y="890"/>
+            <a:ext cx="4809898" cy="6856214"/>
+          </a:xfrm>
+          <a:prstGeom prst="rect">
+            <a:avLst/>
+          </a:prstGeom>
+        </p:spPr>
+      </p:pic>
+      <p:sp>
+        <p:nvSpPr>
+          <p:cNvPr id="6" name="직사각형 5"/>
           <p:cNvSpPr/>
           <p:nvPr/>
         </p:nvSpPr>
         <p:spPr>
           <a:xfrm>
-            <a:off x="0" y="0"/>
-            <a:ext cx="12188952" cy="6858000"/>
+            <a:off x="-1" y="1879560"/>
+            <a:ext cx="12188826" cy="2576274"/>
           </a:xfrm>
           <a:prstGeom prst="rect">
             <a:avLst/>
           </a:prstGeom>
           <a:solidFill>
-            <a:srgbClr val="0A1E5C"/>
+            <a:schemeClr val="tx1">
+              <a:alpha val="55000"/>
+            </a:schemeClr>
           </a:solidFill>
           <a:ln>
             <a:noFill/>
           </a:ln>
         </p:spPr>
         <p:style>
-          <a:lnRef idx="1">
-            <a:schemeClr val="accent1"/>
+          <a:lnRef idx="2">
+            <a:schemeClr val="accent1">
+              <a:shade val="15000"/>
+            </a:schemeClr>
           </a:lnRef>
-          <a:fillRef idx="3">
+          <a:fillRef idx="1">
             <a:schemeClr val="accent1"/>
           </a:fillRef>
-          <a:effectRef idx="2">
+          <a:effectRef idx="0">
             <a:schemeClr val="accent1"/>
           </a:effectRef>
           <a:fontRef idx="minor">
@@ -21783,285 +21574,50 @@
           <a:bodyPr rtlCol="0" anchor="ctr"/>
           <a:lstStyle/>
           <a:p>
-            <a:pPr algn="ctr"/>
-            <a:endParaRPr/>
+            <a:pPr algn="ctr" defTabSz="914400" latinLnBrk="1">
+              <a:defRPr/>
+            </a:pPr>
+            <a:r>
+              <a:rPr lang="en-US" altLang="ko-KR" sz="2400" dirty="0">
+                <a:solidFill>
+                  <a:prstClr val="white"/>
+                </a:solidFill>
+                <a:latin typeface="Hiragino Kaku Gothic Std W8" panose="020B0800000000000000" pitchFamily="34" charset="-128"/>
+                <a:ea typeface="Hiragino Kaku Gothic Std W8" panose="020B0800000000000000" pitchFamily="34" charset="-128"/>
+              </a:rPr>
+              <a:t>Thank You</a:t>
+            </a:r>
+          </a:p>
+          <a:p>
+            <a:pPr algn="ctr" defTabSz="914400" latinLnBrk="1">
+              <a:defRPr/>
+            </a:pPr>
+            <a:endParaRPr lang="ko-KR" altLang="en-US" sz="2400" dirty="0">
+              <a:solidFill>
+                <a:prstClr val="white"/>
+              </a:solidFill>
+              <a:latin typeface="Hiragino Kaku Gothic Std W8" panose="020B0800000000000000" pitchFamily="34" charset="-128"/>
+              <a:ea typeface="Malgun Gothic" panose="020B0503020000020004" pitchFamily="50" charset="-127"/>
+            </a:endParaRPr>
           </a:p>
         </p:txBody>
       </p:sp>
       <p:sp>
         <p:nvSpPr>
-          <p:cNvPr id="3" name="Rectangle 2"/>
-          <p:cNvSpPr/>
+          <p:cNvPr id="2" name="TextBox 1">
+            <a:extLst>
+              <a:ext uri="{FF2B5EF4-FFF2-40B4-BE49-F238E27FC236}">
+                <a16:creationId xmlns:a16="http://schemas.microsoft.com/office/drawing/2014/main" id="{2F61AF39-0AAB-DF66-D56E-AE0B151F775E}"/>
+              </a:ext>
+            </a:extLst>
+          </p:cNvPr>
+          <p:cNvSpPr txBox="1"/>
           <p:nvPr/>
         </p:nvSpPr>
         <p:spPr>
           <a:xfrm>
-            <a:off x="0" y="2606040"/>
-            <a:ext cx="12188952" cy="1051560"/>
-          </a:xfrm>
-          <a:prstGeom prst="rect">
-            <a:avLst/>
-          </a:prstGeom>
-          <a:solidFill>
-            <a:srgbClr val="143070"/>
-          </a:solidFill>
-          <a:ln>
-            <a:noFill/>
-          </a:ln>
-        </p:spPr>
-        <p:style>
-          <a:lnRef idx="1">
-            <a:schemeClr val="accent1"/>
-          </a:lnRef>
-          <a:fillRef idx="3">
-            <a:schemeClr val="accent1"/>
-          </a:fillRef>
-          <a:effectRef idx="2">
-            <a:schemeClr val="accent1"/>
-          </a:effectRef>
-          <a:fontRef idx="minor">
-            <a:schemeClr val="lt1"/>
-          </a:fontRef>
-        </p:style>
-        <p:txBody>
-          <a:bodyPr rtlCol="0" anchor="ctr"/>
-          <a:lstStyle/>
-          <a:p>
-            <a:pPr algn="ctr"/>
-            <a:endParaRPr/>
-          </a:p>
-        </p:txBody>
-      </p:sp>
-      <p:sp>
-        <p:nvSpPr>
-          <p:cNvPr id="4" name="Oval 3"/>
-          <p:cNvSpPr/>
-          <p:nvPr/>
-        </p:nvSpPr>
-        <p:spPr>
-          <a:xfrm>
-            <a:off x="91440" y="0"/>
-            <a:ext cx="3474720" cy="3474720"/>
-          </a:xfrm>
-          <a:prstGeom prst="ellipse">
-            <a:avLst/>
-          </a:prstGeom>
-          <a:solidFill>
-            <a:srgbClr val="FFFFFF"/>
-          </a:solidFill>
-          <a:ln>
-            <a:noFill/>
-          </a:ln>
-        </p:spPr>
-        <p:style>
-          <a:lnRef idx="1">
-            <a:schemeClr val="accent1"/>
-          </a:lnRef>
-          <a:fillRef idx="3">
-            <a:schemeClr val="accent1"/>
-          </a:fillRef>
-          <a:effectRef idx="2">
-            <a:schemeClr val="accent1"/>
-          </a:effectRef>
-          <a:fontRef idx="minor">
-            <a:schemeClr val="lt1"/>
-          </a:fontRef>
-        </p:style>
-        <p:txBody>
-          <a:bodyPr rtlCol="0" anchor="ctr"/>
-          <a:lstStyle/>
-          <a:p>
-            <a:pPr algn="ctr"/>
-            <a:endParaRPr/>
-          </a:p>
-        </p:txBody>
-      </p:sp>
-      <p:sp>
-        <p:nvSpPr>
-          <p:cNvPr id="5" name="Oval 4"/>
-          <p:cNvSpPr/>
-          <p:nvPr/>
-        </p:nvSpPr>
-        <p:spPr>
-          <a:xfrm>
-            <a:off x="502920" y="411480"/>
-            <a:ext cx="2651760" cy="2651760"/>
-          </a:xfrm>
-          <a:prstGeom prst="ellipse">
-            <a:avLst/>
-          </a:prstGeom>
-          <a:solidFill>
-            <a:srgbClr val="0A1E5C"/>
-          </a:solidFill>
-          <a:ln>
-            <a:noFill/>
-          </a:ln>
-        </p:spPr>
-        <p:style>
-          <a:lnRef idx="1">
-            <a:schemeClr val="accent1"/>
-          </a:lnRef>
-          <a:fillRef idx="3">
-            <a:schemeClr val="accent1"/>
-          </a:fillRef>
-          <a:effectRef idx="2">
-            <a:schemeClr val="accent1"/>
-          </a:effectRef>
-          <a:fontRef idx="minor">
-            <a:schemeClr val="lt1"/>
-          </a:fontRef>
-        </p:style>
-        <p:txBody>
-          <a:bodyPr rtlCol="0" anchor="ctr"/>
-          <a:lstStyle/>
-          <a:p>
-            <a:pPr algn="ctr"/>
-            <a:endParaRPr/>
-          </a:p>
-        </p:txBody>
-      </p:sp>
-      <p:sp>
-        <p:nvSpPr>
-          <p:cNvPr id="6" name="Oval 5"/>
-          <p:cNvSpPr/>
-          <p:nvPr/>
-        </p:nvSpPr>
-        <p:spPr>
-          <a:xfrm>
-            <a:off x="91440" y="4023360"/>
-            <a:ext cx="3291840" cy="3291840"/>
-          </a:xfrm>
-          <a:prstGeom prst="ellipse">
-            <a:avLst/>
-          </a:prstGeom>
-          <a:solidFill>
-            <a:srgbClr val="FFFFFF"/>
-          </a:solidFill>
-          <a:ln>
-            <a:noFill/>
-          </a:ln>
-        </p:spPr>
-        <p:style>
-          <a:lnRef idx="1">
-            <a:schemeClr val="accent1"/>
-          </a:lnRef>
-          <a:fillRef idx="3">
-            <a:schemeClr val="accent1"/>
-          </a:fillRef>
-          <a:effectRef idx="2">
-            <a:schemeClr val="accent1"/>
-          </a:effectRef>
-          <a:fontRef idx="minor">
-            <a:schemeClr val="lt1"/>
-          </a:fontRef>
-        </p:style>
-        <p:txBody>
-          <a:bodyPr rtlCol="0" anchor="ctr"/>
-          <a:lstStyle/>
-          <a:p>
-            <a:pPr algn="ctr"/>
-            <a:endParaRPr/>
-          </a:p>
-        </p:txBody>
-      </p:sp>
-      <p:sp>
-        <p:nvSpPr>
-          <p:cNvPr id="7" name="Oval 6"/>
-          <p:cNvSpPr/>
-          <p:nvPr/>
-        </p:nvSpPr>
-        <p:spPr>
-          <a:xfrm>
-            <a:off x="594360" y="4434840"/>
-            <a:ext cx="2286000" cy="2286000"/>
-          </a:xfrm>
-          <a:prstGeom prst="ellipse">
-            <a:avLst/>
-          </a:prstGeom>
-          <a:solidFill>
-            <a:srgbClr val="0A1E5C"/>
-          </a:solidFill>
-          <a:ln>
-            <a:noFill/>
-          </a:ln>
-        </p:spPr>
-        <p:style>
-          <a:lnRef idx="1">
-            <a:schemeClr val="accent1"/>
-          </a:lnRef>
-          <a:fillRef idx="3">
-            <a:schemeClr val="accent1"/>
-          </a:fillRef>
-          <a:effectRef idx="2">
-            <a:schemeClr val="accent1"/>
-          </a:effectRef>
-          <a:fontRef idx="minor">
-            <a:schemeClr val="lt1"/>
-          </a:fontRef>
-        </p:style>
-        <p:txBody>
-          <a:bodyPr rtlCol="0" anchor="ctr"/>
-          <a:lstStyle/>
-          <a:p>
-            <a:pPr algn="ctr"/>
-            <a:endParaRPr/>
-          </a:p>
-        </p:txBody>
-      </p:sp>
-      <p:sp>
-        <p:nvSpPr>
-          <p:cNvPr id="8" name="Rectangle 7"/>
-          <p:cNvSpPr/>
-          <p:nvPr/>
-        </p:nvSpPr>
-        <p:spPr>
-          <a:xfrm>
-            <a:off x="0" y="2331720"/>
-            <a:ext cx="3474720" cy="548640"/>
-          </a:xfrm>
-          <a:prstGeom prst="rect">
-            <a:avLst/>
-          </a:prstGeom>
-          <a:solidFill>
-            <a:srgbClr val="555566"/>
-          </a:solidFill>
-          <a:ln>
-            <a:noFill/>
-          </a:ln>
-        </p:spPr>
-        <p:style>
-          <a:lnRef idx="1">
-            <a:schemeClr val="accent1"/>
-          </a:lnRef>
-          <a:fillRef idx="3">
-            <a:schemeClr val="accent1"/>
-          </a:fillRef>
-          <a:effectRef idx="2">
-            <a:schemeClr val="accent1"/>
-          </a:effectRef>
-          <a:fontRef idx="minor">
-            <a:schemeClr val="lt1"/>
-          </a:fontRef>
-        </p:style>
-        <p:txBody>
-          <a:bodyPr rtlCol="0" anchor="ctr"/>
-          <a:lstStyle/>
-          <a:p>
-            <a:pPr algn="ctr"/>
-            <a:endParaRPr/>
-          </a:p>
-        </p:txBody>
-      </p:sp>
-      <p:sp>
-        <p:nvSpPr>
-          <p:cNvPr id="9" name="TextBox 8"/>
-          <p:cNvSpPr txBox="1"/>
-          <p:nvPr/>
-        </p:nvSpPr>
-        <p:spPr>
-          <a:xfrm>
-            <a:off x="3657600" y="2606040"/>
-            <a:ext cx="8046720" cy="548640"/>
+            <a:off x="6094095" y="5560060"/>
+            <a:ext cx="5842635" cy="1200329"/>
           </a:xfrm>
           <a:prstGeom prst="rect">
             <a:avLst/>
@@ -22069,137 +21625,65 @@
           <a:noFill/>
         </p:spPr>
         <p:txBody>
-          <a:bodyPr wrap="square">
+          <a:bodyPr wrap="square" rtlCol="0">
             <a:spAutoFit/>
           </a:bodyPr>
           <a:lstStyle/>
           <a:p>
-            <a:pPr algn="l"/>
-            <a:r>
-              <a:rPr sz="2800" b="0" i="0">
+            <a:r>
+              <a:rPr lang="en-US" altLang="ko-KR" sz="1800" b="1" dirty="0">
+                <a:solidFill>
+                  <a:schemeClr val="bg1"/>
+                </a:solidFill>
+              </a:rPr>
+              <a:t>Yonsei GSIS 2026-1 </a:t>
+            </a:r>
+          </a:p>
+          <a:p>
+            <a:r>
+              <a:rPr lang="en-US" altLang="ko-KR" sz="1800" b="1" dirty="0">
+                <a:solidFill>
+                  <a:schemeClr val="bg1"/>
+                </a:solidFill>
+              </a:rPr>
+              <a:t>Topics in International Finance</a:t>
+            </a:r>
+            <a:endParaRPr lang="en-US" altLang="ko-KR" sz="1800" dirty="0">
+              <a:solidFill>
+                <a:schemeClr val="bg1"/>
+              </a:solidFill>
+            </a:endParaRPr>
+          </a:p>
+          <a:p>
+            <a:r>
+              <a:rPr lang="en-US" altLang="ko-KR" b="1" dirty="0">
                 <a:solidFill>
                   <a:srgbClr val="FFFFFF"/>
                 </a:solidFill>
-                <a:latin typeface="Calibri Light"/>
-              </a:rPr>
-              <a:t>THANK YOU</a:t>
-            </a:r>
-          </a:p>
-        </p:txBody>
-      </p:sp>
-      <p:sp>
-        <p:nvSpPr>
-          <p:cNvPr id="10" name="TextBox 9"/>
-          <p:cNvSpPr txBox="1"/>
-          <p:nvPr/>
-        </p:nvSpPr>
-        <p:spPr>
-          <a:xfrm>
-            <a:off x="3657600" y="3200400"/>
-            <a:ext cx="8229600" cy="365760"/>
-          </a:xfrm>
-          <a:prstGeom prst="rect">
-            <a:avLst/>
-          </a:prstGeom>
-          <a:noFill/>
-        </p:spPr>
-        <p:txBody>
-          <a:bodyPr wrap="square">
-            <a:spAutoFit/>
-          </a:bodyPr>
-          <a:lstStyle/>
-          <a:p>
-            <a:pPr algn="l"/>
-            <a:r>
-              <a:rPr sz="1300" b="0" i="1">
-                <a:solidFill>
-                  <a:srgbClr val="AAC4E8"/>
-                </a:solidFill>
-                <a:latin typeface="Calibri"/>
-              </a:rPr>
-              <a:t>Event study corrected (insignificant)  ·  TRIM confirms q* = 13%  ·  LSTAR validates the threshold</a:t>
-            </a:r>
-          </a:p>
-        </p:txBody>
-      </p:sp>
-      <p:sp>
-        <p:nvSpPr>
-          <p:cNvPr id="11" name="Rectangle 10"/>
-          <p:cNvSpPr/>
-          <p:nvPr/>
-        </p:nvSpPr>
-        <p:spPr>
-          <a:xfrm>
-            <a:off x="3566160" y="4069080"/>
-            <a:ext cx="6858000" cy="2560320"/>
-          </a:xfrm>
-          <a:prstGeom prst="rect">
-            <a:avLst/>
-          </a:prstGeom>
-          <a:solidFill>
-            <a:srgbClr val="0E2668"/>
-          </a:solidFill>
-          <a:ln>
-            <a:noFill/>
-          </a:ln>
-        </p:spPr>
-        <p:style>
-          <a:lnRef idx="1">
-            <a:schemeClr val="accent1"/>
-          </a:lnRef>
-          <a:fillRef idx="3">
-            <a:schemeClr val="accent1"/>
-          </a:fillRef>
-          <a:effectRef idx="2">
-            <a:schemeClr val="accent1"/>
-          </a:effectRef>
-          <a:fontRef idx="minor">
-            <a:schemeClr val="lt1"/>
-          </a:fontRef>
-        </p:style>
-        <p:txBody>
-          <a:bodyPr rtlCol="0" anchor="ctr"/>
-          <a:lstStyle/>
-          <a:p>
-            <a:pPr algn="ctr"/>
-            <a:endParaRPr/>
-          </a:p>
-        </p:txBody>
-      </p:sp>
-      <p:sp>
-        <p:nvSpPr>
-          <p:cNvPr id="12" name="TextBox 11"/>
-          <p:cNvSpPr txBox="1"/>
-          <p:nvPr/>
-        </p:nvSpPr>
-        <p:spPr>
-          <a:xfrm>
-            <a:off x="3749039" y="4206240"/>
-            <a:ext cx="6583680" cy="2286000"/>
-          </a:xfrm>
-          <a:prstGeom prst="rect">
-            <a:avLst/>
-          </a:prstGeom>
-          <a:noFill/>
-        </p:spPr>
-        <p:txBody>
-          <a:bodyPr wrap="square">
-            <a:spAutoFit/>
-          </a:bodyPr>
-          <a:lstStyle/>
-          <a:p>
-            <a:pPr algn="l"/>
-            <a:r>
-              <a:rPr sz="1600" b="0" i="0">
+              </a:rPr>
+              <a:t>Mireu Kim · Sara Chekroune · Oybek Ibragimov · Jade Zhu  Alexandre Godefroy · Baptiste Degand · </a:t>
+            </a:r>
+            <a:r>
+              <a:rPr lang="en-US" altLang="ko-KR" b="1" dirty="0" err="1">
                 <a:solidFill>
                   <a:srgbClr val="FFFFFF"/>
                 </a:solidFill>
-                <a:latin typeface="Calibri"/>
-              </a:rPr>
-              <a:t>Yonsei GSIS 2026-1  |  Topics in International Finance
-Mireu Kim · Sara Chekroune · Oybek Ibragimov
-kimmireu0921@gmail.com</a:t>
-            </a:r>
+              </a:rPr>
+              <a:t>Minjin</a:t>
+            </a:r>
+            <a:r>
+              <a:rPr lang="en-US" altLang="ko-KR" b="1" dirty="0">
+                <a:solidFill>
+                  <a:srgbClr val="FFFFFF"/>
+                </a:solidFill>
+              </a:rPr>
+              <a:t> Kim </a:t>
+            </a:r>
+            <a:endParaRPr lang="en-US" altLang="ko-KR" sz="1800" b="1" dirty="0">
+              <a:solidFill>
+                <a:srgbClr val="FFFFFF"/>
+              </a:solidFill>
+            </a:endParaRPr>
           </a:p>
         </p:txBody>
       </p:sp>

</xml_diff>